<commit_message>
docs: refresh final presentation test count
Slide 10: 279 passed, 1 skipped (full suite in the Spark/app venv); slide 4 runtime now reads the latest logged ETL run (108 s).

Co-Authored-By: Claude Opus 5.5 <noreply@anthropic.com>
</commit_message>
<xml_diff>
--- a/Documentation/Final/Final_Presentation.pptx
+++ b/Documentation/Final/Final_Presentation.pptx
@@ -4962,7 +4962,7 @@
       </p:sp>
       <p:sp>
         <p:nvSpPr>
-          <p:cNvPr id="3" name="stat tests passing (project + Spark/app env)"/>
+          <p:cNvPr id="3" name="stat passed, 1 skipped: full suite in the Spark/app venv"/>
           <p:cNvSpPr/>
           <p:nvPr/>
         </p:nvSpPr>
@@ -5040,7 +5040,7 @@
                 </a:solidFill>
                 <a:latin typeface="Cambria"/>
               </a:rPr>
-              <a:t>268 + 36</a:t>
+              <a:t>279</a:t>
             </a:r>
           </a:p>
         </p:txBody>
@@ -5079,7 +5079,7 @@
                 </a:solidFill>
                 <a:latin typeface="Calibri"/>
               </a:rPr>
-              <a:t>tests passing (project + Spark/app env)</a:t>
+              <a:t>passed, 1 skipped: full suite in the Spark/app venv</a:t>
             </a:r>
           </a:p>
         </p:txBody>
@@ -8372,7 +8372,7 @@
                 </a:solidFill>
                 <a:latin typeface="Cambria"/>
               </a:rPr>
-              <a:t>109 s</a:t>
+              <a:t>108 s</a:t>
             </a:r>
           </a:p>
         </p:txBody>

</xml_diff>